<commit_message>
feat & bug fix: adicionando três novos robôs, corrigindo a verificação de erros na compilação
</commit_message>
<xml_diff>
--- a/apresentacao/apresentacao_compiler_arena.pptx
+++ b/apresentacao/apresentacao_compiler_arena.pptx
@@ -869,7 +869,7 @@
           <a:lstStyle/>
           <a:p>
             <a:r>
-              <a:t>Cada opcode consome orçamento, inclusive saltos e HALT. A emissão de um comando cede a VM. Scan é um comando, e seu resultado só entra no snapshot seguinte. Todos os ataques usam o início do tick; custos e dano são acumulados antes da eliminação.</a:t>
+              <a:t>Cada opcode consome orçamento, inclusive saltos e HALT. A emissão de um comando cede a VM. Scan é um comando, e seu resultado só entra no snapshot seguinte. Disparos partem do início do tick e criam projéteis que avançam 30 por tick junto com os robôs; custos, regeneração e dano são acumulados antes da eliminação.</a:t>
             </a:r>
           </a:p>
         </p:txBody>
@@ -1009,7 +1009,7 @@
           <a:lstStyle/>
           <a:p>
             <a:r>
-              <a:t>Captura real da arena HTML após quatro ticks da mesma batalha Alpha/Beta. A única simulação vive no servidor Python; o canvas interpola snapshots e anima disparos com o alvo e o dano informados pelo servidor. A velocidade inicial é 1 tick por segundo. O renderizador inverte y para desenhar. A simulação usa coordenadas cartesianas. Mostre na demonstração os botões pausar e passo. Uma VM finalizada pode ser atingida fisicamente.</a:t>
+              <a:t>Captura real da arena HTML após nove ticks da mesma batalha Alpha/Beta, com projéteis em voo. A única simulação vive no servidor Python; o canvas interpola as posições dos projéteis e anima impactos com o alvo e o dano informados pelo servidor. Vida e energia são separadas; a energia regenera. A velocidade inicial é 1 tick por segundo. O renderizador inverte y para desenhar. A simulação usa coordenadas cartesianas. Mostre na demonstração os botões pausar e passo. Uma VM finalizada pode ser atingida fisicamente.</a:t>
             </a:r>
           </a:p>
         </p:txBody>
@@ -7756,7 +7756,7 @@
                 </a:solidFill>
                 <a:latin typeface="DejaVu Sans"/>
               </a:rPr>
-              <a:t>• 1  Snapshot: posições, energia e último scan.</a:t>
+              <a:t>• 1  Snapshot: posições, vida, energia e último scan.</a:t>
             </a:r>
           </a:p>
         </p:txBody>
@@ -7840,7 +7840,7 @@
                 </a:solidFill>
                 <a:latin typeface="DejaVu Sans"/>
               </a:rPr>
-              <a:t>• 3  Ações: movimento, rotação, scan e tiro.</a:t>
+              <a:t>• 3  Ações: movimento, rotação, scan e disparo.</a:t>
             </a:r>
           </a:p>
         </p:txBody>
@@ -7882,7 +7882,7 @@
                 </a:solidFill>
                 <a:latin typeface="DejaVu Sans"/>
               </a:rPr>
-              <a:t>• 4  Custos e dano simultâneos; eliminação.</a:t>
+              <a:t>• 4  Projéteis avançam; custos e dano simultâneos.</a:t>
             </a:r>
           </a:p>
         </p:txBody>
@@ -8446,7 +8446,7 @@
                 </a:solidFill>
                 <a:latin typeface="DejaVu Sans"/>
               </a:rPr>
-              <a:t>Execução de referência: Alpha venceu no tick 10.</a:t>
+              <a:t>Execução de referência: Alpha venceu no tick 24.</a:t>
             </a:r>
           </a:p>
         </p:txBody>
@@ -8683,7 +8683,7 @@
                 </a:solidFill>
                 <a:latin typeface="DejaVu Sans"/>
               </a:rPr>
-              <a:t>45 testes / 0.862 s / OK</a:t>
+              <a:t>50 testes / 0.725 s / OK</a:t>
             </a:r>
           </a:p>
         </p:txBody>
@@ -9424,7 +9424,7 @@
                 </a:solidFill>
                 <a:latin typeface="DejaVu Sans"/>
               </a:rPr>
-              <a:t>Tiros instantâneos, sem projéteis</a:t>
+              <a:t>Sem sensor de projéteis em voo</a:t>
             </a:r>
           </a:p>
         </p:txBody>

</xml_diff>